<commit_message>
Synchronisation vom 18.08.2026 12:31:43,50
</commit_message>
<xml_diff>
--- a/Bericht_Wirtschafltichkeit-Design-V1.pptx
+++ b/Bericht_Wirtschafltichkeit-Design-V1.pptx
@@ -110,6 +110,11 @@
       </a:defRPr>
     </a:lvl9pPr>
   </p:defaultTextStyle>
+  <p:extLst>
+    <p:ext uri="{EFAFB233-063F-42B5-8137-9DF3F51BA10A}">
+      <p15:sldGuideLst xmlns:p15="http://schemas.microsoft.com/office/powerpoint/2012/main"/>
+    </p:ext>
+  </p:extLst>
 </p:presentation>
 </file>
 
@@ -260,7 +265,7 @@
           <a:p>
             <a:fld id="{C87E3102-00BD-4C34-90DF-5B426C8D0011}" type="datetimeFigureOut">
               <a:rPr lang="de-DE" smtClean="0"/>
-              <a:t>16.08.2026</a:t>
+              <a:t>18.08.2026</a:t>
             </a:fld>
             <a:endParaRPr lang="de-DE"/>
           </a:p>
@@ -458,7 +463,7 @@
           <a:p>
             <a:fld id="{C87E3102-00BD-4C34-90DF-5B426C8D0011}" type="datetimeFigureOut">
               <a:rPr lang="de-DE" smtClean="0"/>
-              <a:t>16.08.2026</a:t>
+              <a:t>18.08.2026</a:t>
             </a:fld>
             <a:endParaRPr lang="de-DE"/>
           </a:p>
@@ -666,7 +671,7 @@
           <a:p>
             <a:fld id="{C87E3102-00BD-4C34-90DF-5B426C8D0011}" type="datetimeFigureOut">
               <a:rPr lang="de-DE" smtClean="0"/>
-              <a:t>16.08.2026</a:t>
+              <a:t>18.08.2026</a:t>
             </a:fld>
             <a:endParaRPr lang="de-DE"/>
           </a:p>
@@ -864,7 +869,7 @@
           <a:p>
             <a:fld id="{C87E3102-00BD-4C34-90DF-5B426C8D0011}" type="datetimeFigureOut">
               <a:rPr lang="de-DE" smtClean="0"/>
-              <a:t>16.08.2026</a:t>
+              <a:t>18.08.2026</a:t>
             </a:fld>
             <a:endParaRPr lang="de-DE"/>
           </a:p>
@@ -1139,7 +1144,7 @@
           <a:p>
             <a:fld id="{C87E3102-00BD-4C34-90DF-5B426C8D0011}" type="datetimeFigureOut">
               <a:rPr lang="de-DE" smtClean="0"/>
-              <a:t>16.08.2026</a:t>
+              <a:t>18.08.2026</a:t>
             </a:fld>
             <a:endParaRPr lang="de-DE"/>
           </a:p>
@@ -1404,7 +1409,7 @@
           <a:p>
             <a:fld id="{C87E3102-00BD-4C34-90DF-5B426C8D0011}" type="datetimeFigureOut">
               <a:rPr lang="de-DE" smtClean="0"/>
-              <a:t>16.08.2026</a:t>
+              <a:t>18.08.2026</a:t>
             </a:fld>
             <a:endParaRPr lang="de-DE"/>
           </a:p>
@@ -1816,7 +1821,7 @@
           <a:p>
             <a:fld id="{C87E3102-00BD-4C34-90DF-5B426C8D0011}" type="datetimeFigureOut">
               <a:rPr lang="de-DE" smtClean="0"/>
-              <a:t>16.08.2026</a:t>
+              <a:t>18.08.2026</a:t>
             </a:fld>
             <a:endParaRPr lang="de-DE"/>
           </a:p>
@@ -1957,7 +1962,7 @@
           <a:p>
             <a:fld id="{C87E3102-00BD-4C34-90DF-5B426C8D0011}" type="datetimeFigureOut">
               <a:rPr lang="de-DE" smtClean="0"/>
-              <a:t>16.08.2026</a:t>
+              <a:t>18.08.2026</a:t>
             </a:fld>
             <a:endParaRPr lang="de-DE"/>
           </a:p>
@@ -2070,7 +2075,7 @@
           <a:p>
             <a:fld id="{C87E3102-00BD-4C34-90DF-5B426C8D0011}" type="datetimeFigureOut">
               <a:rPr lang="de-DE" smtClean="0"/>
-              <a:t>16.08.2026</a:t>
+              <a:t>18.08.2026</a:t>
             </a:fld>
             <a:endParaRPr lang="de-DE"/>
           </a:p>
@@ -2381,7 +2386,7 @@
           <a:p>
             <a:fld id="{C87E3102-00BD-4C34-90DF-5B426C8D0011}" type="datetimeFigureOut">
               <a:rPr lang="de-DE" smtClean="0"/>
-              <a:t>16.08.2026</a:t>
+              <a:t>18.08.2026</a:t>
             </a:fld>
             <a:endParaRPr lang="de-DE"/>
           </a:p>
@@ -2669,7 +2674,7 @@
           <a:p>
             <a:fld id="{C87E3102-00BD-4C34-90DF-5B426C8D0011}" type="datetimeFigureOut">
               <a:rPr lang="de-DE" smtClean="0"/>
-              <a:t>16.08.2026</a:t>
+              <a:t>18.08.2026</a:t>
             </a:fld>
             <a:endParaRPr lang="de-DE"/>
           </a:p>
@@ -2910,7 +2915,7 @@
           <a:p>
             <a:fld id="{C87E3102-00BD-4C34-90DF-5B426C8D0011}" type="datetimeFigureOut">
               <a:rPr lang="de-DE" smtClean="0"/>
-              <a:t>16.08.2026</a:t>
+              <a:t>18.08.2026</a:t>
             </a:fld>
             <a:endParaRPr lang="de-DE"/>
           </a:p>
@@ -3388,6 +3393,32 @@
             <a:br>
               <a:rPr lang="de-DE" dirty="0"/>
             </a:br>
+            <a:br>
+              <a:rPr lang="de-DE" dirty="0"/>
+            </a:br>
+            <a:r>
+              <a:rPr lang="de-DE" dirty="0"/>
+              <a:t>Das Desing soll verbessert werden</a:t>
+            </a:r>
+            <a:r>
+              <a:rPr lang="de-DE"/>
+              <a:t>, </a:t>
+            </a:r>
+            <a:r>
+              <a:rPr lang="de-DE" dirty="0"/>
+              <a:t>V</a:t>
+            </a:r>
+            <a:r>
+              <a:rPr lang="de-DE"/>
+              <a:t>orschläge </a:t>
+            </a:r>
+            <a:r>
+              <a:rPr lang="de-DE" dirty="0"/>
+              <a:t>sind nur funktional</a:t>
+            </a:r>
+            <a:br>
+              <a:rPr lang="de-DE" dirty="0"/>
+            </a:br>
             <a:endParaRPr lang="de-DE" dirty="0"/>
           </a:p>
           <a:p>
@@ -3398,112 +3429,6 @@
               <a:rPr lang="de-DE" dirty="0"/>
               <a:t> </a:t>
             </a:r>
-          </a:p>
-        </p:txBody>
-      </p:sp>
-      <p:pic>
-        <p:nvPicPr>
-          <p:cNvPr id="5" name="Grafik 4">
-            <a:extLst>
-              <a:ext uri="{FF2B5EF4-FFF2-40B4-BE49-F238E27FC236}">
-                <a16:creationId xmlns:a16="http://schemas.microsoft.com/office/drawing/2014/main" id="{3D881218-E12C-D105-5AA5-F2573043F391}"/>
-              </a:ext>
-            </a:extLst>
-          </p:cNvPr>
-          <p:cNvPicPr>
-            <a:picLocks noChangeAspect="1"/>
-          </p:cNvPicPr>
-          <p:nvPr/>
-        </p:nvPicPr>
-        <p:blipFill>
-          <a:blip r:embed="rId2"/>
-          <a:stretch>
-            <a:fillRect/>
-          </a:stretch>
-        </p:blipFill>
-        <p:spPr>
-          <a:xfrm>
-            <a:off x="5607256" y="3289443"/>
-            <a:ext cx="6236463" cy="3487691"/>
-          </a:xfrm>
-          <a:prstGeom prst="rect">
-            <a:avLst/>
-          </a:prstGeom>
-        </p:spPr>
-      </p:pic>
-      <p:pic>
-        <p:nvPicPr>
-          <p:cNvPr id="7" name="Grafik 6">
-            <a:extLst>
-              <a:ext uri="{FF2B5EF4-FFF2-40B4-BE49-F238E27FC236}">
-                <a16:creationId xmlns:a16="http://schemas.microsoft.com/office/drawing/2014/main" id="{BC3DE475-6340-568E-B5C1-05E606A56831}"/>
-              </a:ext>
-            </a:extLst>
-          </p:cNvPr>
-          <p:cNvPicPr>
-            <a:picLocks noChangeAspect="1"/>
-          </p:cNvPicPr>
-          <p:nvPr/>
-        </p:nvPicPr>
-        <p:blipFill>
-          <a:blip r:embed="rId3"/>
-          <a:stretch>
-            <a:fillRect/>
-          </a:stretch>
-        </p:blipFill>
-        <p:spPr>
-          <a:xfrm>
-            <a:off x="5521234" y="2758401"/>
-            <a:ext cx="3378374" cy="463574"/>
-          </a:xfrm>
-          <a:prstGeom prst="rect">
-            <a:avLst/>
-          </a:prstGeom>
-        </p:spPr>
-      </p:pic>
-      <p:sp>
-        <p:nvSpPr>
-          <p:cNvPr id="8" name="Pfeil: nach unten 7">
-            <a:extLst>
-              <a:ext uri="{FF2B5EF4-FFF2-40B4-BE49-F238E27FC236}">
-                <a16:creationId xmlns:a16="http://schemas.microsoft.com/office/drawing/2014/main" id="{D9C74AB9-78DD-9BF3-FEBE-5CCA42B7373F}"/>
-              </a:ext>
-            </a:extLst>
-          </p:cNvPr>
-          <p:cNvSpPr/>
-          <p:nvPr/>
-        </p:nvSpPr>
-        <p:spPr>
-          <a:xfrm>
-            <a:off x="5840743" y="3165431"/>
-            <a:ext cx="370114" cy="435429"/>
-          </a:xfrm>
-          <a:prstGeom prst="downArrow">
-            <a:avLst/>
-          </a:prstGeom>
-        </p:spPr>
-        <p:style>
-          <a:lnRef idx="2">
-            <a:schemeClr val="accent1">
-              <a:shade val="15000"/>
-            </a:schemeClr>
-          </a:lnRef>
-          <a:fillRef idx="1">
-            <a:schemeClr val="accent1"/>
-          </a:fillRef>
-          <a:effectRef idx="0">
-            <a:schemeClr val="accent1"/>
-          </a:effectRef>
-          <a:fontRef idx="minor">
-            <a:schemeClr val="lt1"/>
-          </a:fontRef>
-        </p:style>
-        <p:txBody>
-          <a:bodyPr rtlCol="0" anchor="ctr"/>
-          <a:lstStyle/>
-          <a:p>
-            <a:pPr algn="ctr"/>
-            <a:endParaRPr lang="de-DE"/>
           </a:p>
         </p:txBody>
       </p:sp>
@@ -3734,7 +3659,7 @@
         </p:blipFill>
         <p:spPr>
           <a:xfrm>
-            <a:off x="521040" y="1678661"/>
+            <a:off x="548219" y="1186714"/>
             <a:ext cx="4312218" cy="407033"/>
           </a:xfrm>
           <a:prstGeom prst="rect">
@@ -3764,8 +3689,8 @@
         </p:blipFill>
         <p:spPr>
           <a:xfrm>
-            <a:off x="5909685" y="1569804"/>
-            <a:ext cx="4929962" cy="2665074"/>
+            <a:off x="631908" y="1765418"/>
+            <a:ext cx="4887260" cy="3757558"/>
           </a:xfrm>
           <a:prstGeom prst="rect">
             <a:avLst/>
@@ -3794,7 +3719,7 @@
         </p:blipFill>
         <p:spPr>
           <a:xfrm>
-            <a:off x="3364492" y="2235470"/>
+            <a:off x="8750308" y="1055678"/>
             <a:ext cx="1883112" cy="288477"/>
           </a:xfrm>
           <a:prstGeom prst="rect">
@@ -3824,7 +3749,7 @@
         </p:blipFill>
         <p:spPr>
           <a:xfrm>
-            <a:off x="424021" y="2268350"/>
+            <a:off x="5654389" y="1287717"/>
             <a:ext cx="2970013" cy="193230"/>
           </a:xfrm>
           <a:prstGeom prst="rect">
@@ -3854,7 +3779,7 @@
         </p:blipFill>
         <p:spPr>
           <a:xfrm>
-            <a:off x="3364090" y="3891489"/>
+            <a:off x="5018386" y="5913330"/>
             <a:ext cx="2121009" cy="292115"/>
           </a:xfrm>
           <a:prstGeom prst="rect">
@@ -3884,7 +3809,7 @@
         </p:blipFill>
         <p:spPr>
           <a:xfrm>
-            <a:off x="3459347" y="2579311"/>
+            <a:off x="8841748" y="1362947"/>
             <a:ext cx="1930499" cy="311166"/>
           </a:xfrm>
           <a:prstGeom prst="rect">
@@ -4036,6 +3961,75 @@
             <a:r>
               <a:rPr lang="de-DE" sz="1400" dirty="0"/>
               <a:t>Übersicht</a:t>
+            </a:r>
+          </a:p>
+        </p:txBody>
+      </p:sp>
+      <p:sp>
+        <p:nvSpPr>
+          <p:cNvPr id="2" name="Rechteck 1">
+            <a:extLst>
+              <a:ext uri="{FF2B5EF4-FFF2-40B4-BE49-F238E27FC236}">
+                <a16:creationId xmlns:a16="http://schemas.microsoft.com/office/drawing/2014/main" id="{E8909A5A-9198-1618-E24B-765D4FD1E7C4}"/>
+              </a:ext>
+            </a:extLst>
+          </p:cNvPr>
+          <p:cNvSpPr/>
+          <p:nvPr/>
+        </p:nvSpPr>
+        <p:spPr>
+          <a:xfrm>
+            <a:off x="5998464" y="2103120"/>
+            <a:ext cx="4471416" cy="3139321"/>
+          </a:xfrm>
+          <a:prstGeom prst="rect">
+            <a:avLst/>
+          </a:prstGeom>
+        </p:spPr>
+        <p:style>
+          <a:lnRef idx="2">
+            <a:schemeClr val="accent1">
+              <a:shade val="15000"/>
+            </a:schemeClr>
+          </a:lnRef>
+          <a:fillRef idx="1">
+            <a:schemeClr val="accent1"/>
+          </a:fillRef>
+          <a:effectRef idx="0">
+            <a:schemeClr val="accent1"/>
+          </a:effectRef>
+          <a:fontRef idx="minor">
+            <a:schemeClr val="lt1"/>
+          </a:fontRef>
+        </p:style>
+        <p:txBody>
+          <a:bodyPr rtlCol="0" anchor="t" anchorCtr="0">
+            <a:spAutoFit/>
+          </a:bodyPr>
+          <a:lstStyle/>
+          <a:p>
+            <a:r>
+              <a:rPr lang="de-DE" dirty="0"/>
+              <a:t>Bei Klick auf Projekt/Variante:</a:t>
+            </a:r>
+          </a:p>
+          <a:p>
+            <a:br>
+              <a:rPr lang="de-DE" dirty="0"/>
+            </a:br>
+            <a:r>
+              <a:rPr lang="de-DE" dirty="0"/>
+              <a:t>Anzeigen der unterschiede der Komponenten zu Stamm, bei Stamm alle Komponenten anzeigen.</a:t>
+            </a:r>
+            <a:br>
+              <a:rPr lang="de-DE" dirty="0"/>
+            </a:br>
+            <a:br>
+              <a:rPr lang="de-DE" dirty="0"/>
+            </a:br>
+            <a:r>
+              <a:rPr lang="de-DE" dirty="0"/>
+              <a:t>Erstelle für jede unterschiedlich Komponente eine Möglichkeit diese aus einer anderen Version (Stamm oder Variante) zu überschreiben (mit dieser Funktionalität)</a:t>
             </a:r>
           </a:p>
         </p:txBody>

</xml_diff>